<commit_message>
Updated articles, data, report and language
</commit_message>
<xml_diff>
--- a/_docs/toolkit_wireframe.pptx
+++ b/_docs/toolkit_wireframe.pptx
@@ -5,16 +5,15 @@
     <p:sldMasterId id="2147483648" r:id="rId4"/>
   </p:sldMasterIdLst>
   <p:notesMasterIdLst>
-    <p:notesMasterId r:id="rId12"/>
+    <p:notesMasterId r:id="rId11"/>
   </p:notesMasterIdLst>
   <p:sldIdLst>
     <p:sldId id="279" r:id="rId5"/>
     <p:sldId id="304" r:id="rId6"/>
-    <p:sldId id="296" r:id="rId7"/>
-    <p:sldId id="302" r:id="rId8"/>
-    <p:sldId id="301" r:id="rId9"/>
-    <p:sldId id="303" r:id="rId10"/>
-    <p:sldId id="305" r:id="rId11"/>
+    <p:sldId id="306" r:id="rId7"/>
+    <p:sldId id="296" r:id="rId8"/>
+    <p:sldId id="302" r:id="rId9"/>
+    <p:sldId id="305" r:id="rId10"/>
   </p:sldIdLst>
   <p:sldSz cx="12192000" cy="6858000"/>
   <p:notesSz cx="6858000" cy="9144000"/>
@@ -122,7 +121,7 @@
 </file>
 
 <file path=ppt/diagrams/colors1.xml><?xml version="1.0" encoding="utf-8"?>
-<dgm:colorsDef xmlns:dgm="http://schemas.openxmlformats.org/drawingml/2006/diagram" xmlns:a="http://schemas.openxmlformats.org/drawingml/2006/main" uniqueId="urn:microsoft.com/office/officeart/2005/8/colors/accent1_2">
+<dgm:colorsDef xmlns:dgm="http://schemas.openxmlformats.org/drawingml/2006/diagram" xmlns:a="http://schemas.openxmlformats.org/drawingml/2006/main" uniqueId="urn:microsoft.com/office/officeart/2005/8/colors/accent1_2#1">
   <dgm:title val=""/>
   <dgm:desc val=""/>
   <dgm:catLst>
@@ -872,7 +871,7 @@
 <dgm:dataModel xmlns:dgm="http://schemas.openxmlformats.org/drawingml/2006/diagram" xmlns:a="http://schemas.openxmlformats.org/drawingml/2006/main">
   <dgm:ptLst>
     <dgm:pt modelId="{082872B8-9830-447E-906C-CBD5683BD825}" type="doc">
-      <dgm:prSet loTypeId="urn:microsoft.com/office/officeart/2005/8/layout/hierarchy3" loCatId="hierarchy" qsTypeId="urn:microsoft.com/office/officeart/2005/8/quickstyle/simple1" qsCatId="simple" csTypeId="urn:microsoft.com/office/officeart/2005/8/colors/accent1_2" csCatId="accent1" phldr="1"/>
+      <dgm:prSet loTypeId="urn:microsoft.com/office/officeart/2005/8/layout/hierarchy3" loCatId="hierarchy" qsTypeId="urn:microsoft.com/office/officeart/2005/8/quickstyle/simple1#1" qsCatId="simple" csTypeId="urn:microsoft.com/office/officeart/2005/8/colors/accent1_2#1" csCatId="accent1" phldr="1"/>
       <dgm:spPr/>
       <dgm:t>
         <a:bodyPr/>
@@ -4141,7 +4140,7 @@
 </file>
 
 <file path=ppt/diagrams/quickStyle1.xml><?xml version="1.0" encoding="utf-8"?>
-<dgm:styleDef xmlns:dgm="http://schemas.openxmlformats.org/drawingml/2006/diagram" xmlns:a="http://schemas.openxmlformats.org/drawingml/2006/main" uniqueId="urn:microsoft.com/office/officeart/2005/8/quickstyle/simple1">
+<dgm:styleDef xmlns:dgm="http://schemas.openxmlformats.org/drawingml/2006/diagram" xmlns:a="http://schemas.openxmlformats.org/drawingml/2006/main" uniqueId="urn:microsoft.com/office/officeart/2005/8/quickstyle/simple1#1">
   <dgm:title val=""/>
   <dgm:desc val=""/>
   <dgm:catLst>
@@ -5256,7 +5255,7 @@
           <a:p>
             <a:fld id="{87650E45-4150-774C-926C-C38E8D3D53A2}" type="datetimeFigureOut">
               <a:rPr lang="en-US" smtClean="0"/>
-              <a:t>8/7/2026</a:t>
+              <a:t>8/24/2026</a:t>
             </a:fld>
             <a:endParaRPr lang="en-US" dirty="0"/>
           </a:p>
@@ -10240,7 +10239,7 @@
             <a:fld id="{EE518CBA-D8B4-47B2-892B-826C26D1B466}" type="datetimeFigureOut">
               <a:rPr lang="en-US" smtClean="0"/>
               <a:pPr/>
-              <a:t>8/7/2026</a:t>
+              <a:t>8/24/2026</a:t>
             </a:fld>
             <a:endParaRPr lang="en-US" dirty="0"/>
           </a:p>
@@ -10899,10 +10898,10 @@
       </p:grpSpPr>
       <p:sp>
         <p:nvSpPr>
-          <p:cNvPr id="3" name="Title 2">
+          <p:cNvPr id="2" name="Title 1">
             <a:extLst>
               <a:ext uri="{FF2B5EF4-FFF2-40B4-BE49-F238E27FC236}">
-                <a16:creationId xmlns:a16="http://schemas.microsoft.com/office/drawing/2014/main" id="{64BB6F2D-E78A-6FE5-1A36-75C74FD93F9F}"/>
+                <a16:creationId xmlns:a16="http://schemas.microsoft.com/office/drawing/2014/main" id="{D4B0BC4A-902B-930D-811C-6BE27068AD43}"/>
               </a:ext>
             </a:extLst>
           </p:cNvPr>
@@ -10913,29 +10912,24 @@
             <p:ph type="title"/>
           </p:nvPr>
         </p:nvSpPr>
-        <p:spPr>
-          <a:xfrm>
-            <a:off x="649045" y="363854"/>
-            <a:ext cx="10780955" cy="1243717"/>
-          </a:xfrm>
-        </p:spPr>
+        <p:spPr/>
         <p:txBody>
           <a:bodyPr/>
           <a:lstStyle/>
           <a:p>
             <a:r>
               <a:rPr lang="en-US" dirty="0"/>
-              <a:t>Actions and activity</a:t>
+              <a:t>Page template</a:t>
             </a:r>
           </a:p>
         </p:txBody>
       </p:sp>
       <p:sp>
         <p:nvSpPr>
-          <p:cNvPr id="9" name="Text Placeholder 8">
+          <p:cNvPr id="3" name="Content Placeholder 2">
             <a:extLst>
               <a:ext uri="{FF2B5EF4-FFF2-40B4-BE49-F238E27FC236}">
-                <a16:creationId xmlns:a16="http://schemas.microsoft.com/office/drawing/2014/main" id="{5214E3D1-6639-F466-7FDE-6564E439499A}"/>
+                <a16:creationId xmlns:a16="http://schemas.microsoft.com/office/drawing/2014/main" id="{C1D9103B-E712-1C30-8F71-1B2A9F374F0A}"/>
               </a:ext>
             </a:extLst>
           </p:cNvPr>
@@ -10946,167 +10940,40 @@
             <p:ph sz="quarter" idx="13"/>
           </p:nvPr>
         </p:nvSpPr>
-        <p:spPr>
-          <a:xfrm>
-            <a:off x="649288" y="2377440"/>
-            <a:ext cx="5157216" cy="3840480"/>
-          </a:xfrm>
-        </p:spPr>
+        <p:spPr/>
         <p:txBody>
           <a:bodyPr/>
           <a:lstStyle/>
           <a:p>
             <a:r>
-              <a:rPr lang="en-US" b="1" dirty="0"/>
-              <a:t>Actions</a:t>
-            </a:r>
-          </a:p>
-          <a:p>
-            <a:pPr lvl="1"/>
-            <a:r>
               <a:rPr lang="en-US" dirty="0"/>
-              <a:t>Datasets</a:t>
-            </a:r>
-          </a:p>
-          <a:p>
-            <a:pPr lvl="1"/>
+              <a:t>What</a:t>
+            </a:r>
+          </a:p>
+          <a:p>
             <a:r>
               <a:rPr lang="en-US" dirty="0"/>
-              <a:t>Apps and maps</a:t>
-            </a:r>
-          </a:p>
-          <a:p>
-            <a:pPr lvl="1"/>
+              <a:t>Why</a:t>
+            </a:r>
+          </a:p>
+          <a:p>
             <a:r>
               <a:rPr lang="en-US" dirty="0"/>
-              <a:t>Data narratives and visualizations</a:t>
-            </a:r>
-          </a:p>
-          <a:p>
-            <a:pPr lvl="1"/>
+              <a:t>How</a:t>
+            </a:r>
+          </a:p>
+          <a:p>
             <a:r>
               <a:rPr lang="en-US" dirty="0"/>
-              <a:t>Data portal as the standard</a:t>
-            </a:r>
-          </a:p>
-          <a:p>
-            <a:pPr lvl="1"/>
-            <a:r>
-              <a:rPr lang="en-US" dirty="0"/>
-              <a:t>Data catalog – inclusive (GIS, community)</a:t>
-            </a:r>
-          </a:p>
-          <a:p>
-            <a:pPr lvl="1"/>
-            <a:r>
-              <a:rPr lang="en-US" dirty="0"/>
-              <a:t>Data quality</a:t>
-            </a:r>
-          </a:p>
-          <a:p>
-            <a:pPr lvl="1"/>
-            <a:r>
-              <a:rPr lang="en-US" dirty="0"/>
-              <a:t>Support and enablement</a:t>
-            </a:r>
-          </a:p>
-        </p:txBody>
-      </p:sp>
-      <p:sp>
-        <p:nvSpPr>
-          <p:cNvPr id="5" name="Text Placeholder 4">
-            <a:extLst>
-              <a:ext uri="{FF2B5EF4-FFF2-40B4-BE49-F238E27FC236}">
-                <a16:creationId xmlns:a16="http://schemas.microsoft.com/office/drawing/2014/main" id="{4886EE38-2957-C862-1C4F-9B0157829E20}"/>
-              </a:ext>
-            </a:extLst>
-          </p:cNvPr>
-          <p:cNvSpPr>
-            <a:spLocks noGrp="1"/>
-          </p:cNvSpPr>
-          <p:nvPr>
-            <p:ph sz="quarter" idx="14"/>
-          </p:nvPr>
-        </p:nvSpPr>
-        <p:spPr>
-          <a:xfrm>
-            <a:off x="6254496" y="2377440"/>
-            <a:ext cx="5157216" cy="3840480"/>
-          </a:xfrm>
-        </p:spPr>
-        <p:txBody>
-          <a:bodyPr>
-            <a:normAutofit lnSpcReduction="10000"/>
-          </a:bodyPr>
-          <a:lstStyle/>
-          <a:p>
-            <a:r>
-              <a:rPr lang="en-US" b="1" dirty="0"/>
-              <a:t>Activity</a:t>
-            </a:r>
-          </a:p>
-          <a:p>
-            <a:pPr lvl="1"/>
-            <a:r>
-              <a:rPr lang="en-US" dirty="0"/>
-              <a:t>Views and downloads of datasets, web pages, applications, tools, websites</a:t>
-            </a:r>
-          </a:p>
-          <a:p>
-            <a:pPr lvl="1"/>
-            <a:r>
-              <a:rPr lang="en-US" dirty="0"/>
-              <a:t>Events</a:t>
-            </a:r>
-          </a:p>
-          <a:p>
-            <a:pPr lvl="1"/>
-            <a:r>
-              <a:rPr lang="en-US" dirty="0"/>
-              <a:t>Communications</a:t>
-            </a:r>
-          </a:p>
-          <a:p>
-            <a:pPr lvl="1"/>
-            <a:r>
-              <a:rPr lang="en-US" dirty="0"/>
-              <a:t>Community work</a:t>
-            </a:r>
-          </a:p>
-          <a:p>
-            <a:pPr lvl="1"/>
-            <a:r>
-              <a:rPr lang="en-US" dirty="0"/>
-              <a:t>Articles, tools, and research</a:t>
-            </a:r>
-          </a:p>
-          <a:p>
-            <a:pPr lvl="1"/>
-            <a:r>
-              <a:rPr lang="en-US" dirty="0"/>
-              <a:t>Public information requests</a:t>
-            </a:r>
-          </a:p>
-          <a:p>
-            <a:pPr lvl="1"/>
-            <a:r>
-              <a:rPr lang="en-US" dirty="0"/>
-              <a:t>Council actions</a:t>
-            </a:r>
-          </a:p>
-          <a:p>
-            <a:pPr lvl="1"/>
-            <a:endParaRPr lang="en-US" dirty="0"/>
-          </a:p>
-          <a:p>
-            <a:endParaRPr lang="en-US" dirty="0"/>
+              <a:t>Examples</a:t>
+            </a:r>
           </a:p>
         </p:txBody>
       </p:sp>
     </p:spTree>
     <p:extLst>
       <p:ext uri="{BB962C8B-B14F-4D97-AF65-F5344CB8AC3E}">
-        <p14:creationId xmlns:p14="http://schemas.microsoft.com/office/powerpoint/2010/main" val="3054502417"/>
+        <p14:creationId xmlns:p14="http://schemas.microsoft.com/office/powerpoint/2010/main" val="3167066443"/>
       </p:ext>
     </p:extLst>
   </p:cSld>
@@ -11149,6 +11016,242 @@
             <p:ph type="title"/>
           </p:nvPr>
         </p:nvSpPr>
+        <p:spPr>
+          <a:xfrm>
+            <a:off x="649045" y="363854"/>
+            <a:ext cx="10780955" cy="1243717"/>
+          </a:xfrm>
+        </p:spPr>
+        <p:txBody>
+          <a:bodyPr/>
+          <a:lstStyle/>
+          <a:p>
+            <a:r>
+              <a:rPr lang="en-US" dirty="0"/>
+              <a:t>Actions and activity</a:t>
+            </a:r>
+          </a:p>
+        </p:txBody>
+      </p:sp>
+      <p:sp>
+        <p:nvSpPr>
+          <p:cNvPr id="9" name="Text Placeholder 8">
+            <a:extLst>
+              <a:ext uri="{FF2B5EF4-FFF2-40B4-BE49-F238E27FC236}">
+                <a16:creationId xmlns:a16="http://schemas.microsoft.com/office/drawing/2014/main" id="{5214E3D1-6639-F466-7FDE-6564E439499A}"/>
+              </a:ext>
+            </a:extLst>
+          </p:cNvPr>
+          <p:cNvSpPr>
+            <a:spLocks noGrp="1"/>
+          </p:cNvSpPr>
+          <p:nvPr>
+            <p:ph sz="quarter" idx="13"/>
+          </p:nvPr>
+        </p:nvSpPr>
+        <p:spPr>
+          <a:xfrm>
+            <a:off x="649288" y="2377440"/>
+            <a:ext cx="5157216" cy="3840480"/>
+          </a:xfrm>
+        </p:spPr>
+        <p:txBody>
+          <a:bodyPr/>
+          <a:lstStyle/>
+          <a:p>
+            <a:r>
+              <a:rPr lang="en-US" b="1" dirty="0"/>
+              <a:t>Actions</a:t>
+            </a:r>
+          </a:p>
+          <a:p>
+            <a:pPr lvl="1"/>
+            <a:r>
+              <a:rPr lang="en-US" dirty="0"/>
+              <a:t>Datasets</a:t>
+            </a:r>
+          </a:p>
+          <a:p>
+            <a:pPr lvl="1"/>
+            <a:r>
+              <a:rPr lang="en-US" dirty="0"/>
+              <a:t>Apps and maps</a:t>
+            </a:r>
+          </a:p>
+          <a:p>
+            <a:pPr lvl="1"/>
+            <a:r>
+              <a:rPr lang="en-US" dirty="0"/>
+              <a:t>Data narratives and visualizations</a:t>
+            </a:r>
+          </a:p>
+          <a:p>
+            <a:pPr lvl="1"/>
+            <a:r>
+              <a:rPr lang="en-US" dirty="0"/>
+              <a:t>Data portal as the standard</a:t>
+            </a:r>
+          </a:p>
+          <a:p>
+            <a:pPr lvl="1"/>
+            <a:r>
+              <a:rPr lang="en-US" dirty="0"/>
+              <a:t>Data catalog – inclusive (GIS, community)</a:t>
+            </a:r>
+          </a:p>
+          <a:p>
+            <a:pPr lvl="1"/>
+            <a:r>
+              <a:rPr lang="en-US" dirty="0"/>
+              <a:t>Data quality</a:t>
+            </a:r>
+          </a:p>
+          <a:p>
+            <a:pPr lvl="1"/>
+            <a:r>
+              <a:rPr lang="en-US" dirty="0"/>
+              <a:t>Support and enablement</a:t>
+            </a:r>
+          </a:p>
+        </p:txBody>
+      </p:sp>
+      <p:sp>
+        <p:nvSpPr>
+          <p:cNvPr id="5" name="Text Placeholder 4">
+            <a:extLst>
+              <a:ext uri="{FF2B5EF4-FFF2-40B4-BE49-F238E27FC236}">
+                <a16:creationId xmlns:a16="http://schemas.microsoft.com/office/drawing/2014/main" id="{4886EE38-2957-C862-1C4F-9B0157829E20}"/>
+              </a:ext>
+            </a:extLst>
+          </p:cNvPr>
+          <p:cNvSpPr>
+            <a:spLocks noGrp="1"/>
+          </p:cNvSpPr>
+          <p:nvPr>
+            <p:ph sz="quarter" idx="14"/>
+          </p:nvPr>
+        </p:nvSpPr>
+        <p:spPr>
+          <a:xfrm>
+            <a:off x="6254496" y="2377440"/>
+            <a:ext cx="5157216" cy="3840480"/>
+          </a:xfrm>
+        </p:spPr>
+        <p:txBody>
+          <a:bodyPr>
+            <a:normAutofit lnSpcReduction="10000"/>
+          </a:bodyPr>
+          <a:lstStyle/>
+          <a:p>
+            <a:r>
+              <a:rPr lang="en-US" b="1" dirty="0"/>
+              <a:t>Activity</a:t>
+            </a:r>
+          </a:p>
+          <a:p>
+            <a:pPr lvl="1"/>
+            <a:r>
+              <a:rPr lang="en-US" dirty="0"/>
+              <a:t>Views and downloads of datasets, web pages, applications, tools, websites</a:t>
+            </a:r>
+          </a:p>
+          <a:p>
+            <a:pPr lvl="1"/>
+            <a:r>
+              <a:rPr lang="en-US" dirty="0"/>
+              <a:t>Events</a:t>
+            </a:r>
+          </a:p>
+          <a:p>
+            <a:pPr lvl="1"/>
+            <a:r>
+              <a:rPr lang="en-US" dirty="0"/>
+              <a:t>Communications</a:t>
+            </a:r>
+          </a:p>
+          <a:p>
+            <a:pPr lvl="1"/>
+            <a:r>
+              <a:rPr lang="en-US" dirty="0"/>
+              <a:t>Community work</a:t>
+            </a:r>
+          </a:p>
+          <a:p>
+            <a:pPr lvl="1"/>
+            <a:r>
+              <a:rPr lang="en-US" dirty="0"/>
+              <a:t>Articles, tools, and research</a:t>
+            </a:r>
+          </a:p>
+          <a:p>
+            <a:pPr lvl="1"/>
+            <a:r>
+              <a:rPr lang="en-US" dirty="0"/>
+              <a:t>Public information requests</a:t>
+            </a:r>
+          </a:p>
+          <a:p>
+            <a:pPr lvl="1"/>
+            <a:r>
+              <a:rPr lang="en-US" dirty="0"/>
+              <a:t>Council actions</a:t>
+            </a:r>
+          </a:p>
+          <a:p>
+            <a:pPr lvl="1"/>
+            <a:endParaRPr lang="en-US" dirty="0"/>
+          </a:p>
+          <a:p>
+            <a:endParaRPr lang="en-US" dirty="0"/>
+          </a:p>
+        </p:txBody>
+      </p:sp>
+    </p:spTree>
+    <p:extLst>
+      <p:ext uri="{BB962C8B-B14F-4D97-AF65-F5344CB8AC3E}">
+        <p14:creationId xmlns:p14="http://schemas.microsoft.com/office/powerpoint/2010/main" val="3054502417"/>
+      </p:ext>
+    </p:extLst>
+  </p:cSld>
+  <p:clrMapOvr>
+    <a:masterClrMapping/>
+  </p:clrMapOvr>
+</p:sld>
+</file>
+
+<file path=ppt/slides/slide5.xml><?xml version="1.0" encoding="utf-8"?>
+<p:sld xmlns:a="http://schemas.openxmlformats.org/drawingml/2006/main" xmlns:r="http://schemas.openxmlformats.org/officeDocument/2006/relationships" xmlns:p="http://schemas.openxmlformats.org/presentationml/2006/main">
+  <p:cSld>
+    <p:spTree>
+      <p:nvGrpSpPr>
+        <p:cNvPr id="1" name=""/>
+        <p:cNvGrpSpPr/>
+        <p:nvPr/>
+      </p:nvGrpSpPr>
+      <p:grpSpPr>
+        <a:xfrm>
+          <a:off x="0" y="0"/>
+          <a:ext cx="0" cy="0"/>
+          <a:chOff x="0" y="0"/>
+          <a:chExt cx="0" cy="0"/>
+        </a:xfrm>
+      </p:grpSpPr>
+      <p:sp>
+        <p:nvSpPr>
+          <p:cNvPr id="3" name="Title 2">
+            <a:extLst>
+              <a:ext uri="{FF2B5EF4-FFF2-40B4-BE49-F238E27FC236}">
+                <a16:creationId xmlns:a16="http://schemas.microsoft.com/office/drawing/2014/main" id="{64BB6F2D-E78A-6FE5-1A36-75C74FD93F9F}"/>
+              </a:ext>
+            </a:extLst>
+          </p:cNvPr>
+          <p:cNvSpPr>
+            <a:spLocks noGrp="1"/>
+          </p:cNvSpPr>
+          <p:nvPr>
+            <p:ph type="title"/>
+          </p:nvPr>
+        </p:nvSpPr>
         <p:spPr/>
         <p:txBody>
           <a:bodyPr>
@@ -11158,7 +11261,7 @@
           <a:p>
             <a:r>
               <a:rPr lang="en-US" dirty="0"/>
-              <a:t>Action: datasets</a:t>
+              <a:t>Organization</a:t>
             </a:r>
           </a:p>
         </p:txBody>
@@ -11207,930 +11310,7 @@
 </p:sld>
 </file>
 
-<file path=ppt/slides/slide5.xml><?xml version="1.0" encoding="utf-8"?>
-<p:sld xmlns:a="http://schemas.openxmlformats.org/drawingml/2006/main" xmlns:r="http://schemas.openxmlformats.org/officeDocument/2006/relationships" xmlns:p="http://schemas.openxmlformats.org/presentationml/2006/main">
-  <p:cSld>
-    <p:spTree>
-      <p:nvGrpSpPr>
-        <p:cNvPr id="1" name=""/>
-        <p:cNvGrpSpPr/>
-        <p:nvPr/>
-      </p:nvGrpSpPr>
-      <p:grpSpPr>
-        <a:xfrm>
-          <a:off x="0" y="0"/>
-          <a:ext cx="0" cy="0"/>
-          <a:chOff x="0" y="0"/>
-          <a:chExt cx="0" cy="0"/>
-        </a:xfrm>
-      </p:grpSpPr>
-      <p:sp>
-        <p:nvSpPr>
-          <p:cNvPr id="18" name="Title 17">
-            <a:extLst>
-              <a:ext uri="{FF2B5EF4-FFF2-40B4-BE49-F238E27FC236}">
-                <a16:creationId xmlns:a16="http://schemas.microsoft.com/office/drawing/2014/main" id="{9F2FEA60-F900-4C56-9486-48EA30926F6E}"/>
-              </a:ext>
-            </a:extLst>
-          </p:cNvPr>
-          <p:cNvSpPr>
-            <a:spLocks noGrp="1"/>
-          </p:cNvSpPr>
-          <p:nvPr>
-            <p:ph type="title"/>
-          </p:nvPr>
-        </p:nvSpPr>
-        <p:spPr>
-          <a:xfrm>
-            <a:off x="649045" y="363854"/>
-            <a:ext cx="10780955" cy="1243717"/>
-          </a:xfrm>
-        </p:spPr>
-        <p:txBody>
-          <a:bodyPr>
-            <a:normAutofit/>
-          </a:bodyPr>
-          <a:lstStyle/>
-          <a:p>
-            <a:r>
-              <a:rPr lang="en-US" dirty="0"/>
-              <a:t>Example measures</a:t>
-            </a:r>
-          </a:p>
-        </p:txBody>
-      </p:sp>
-      <p:sp>
-        <p:nvSpPr>
-          <p:cNvPr id="19" name="Content Placeholder 18">
-            <a:extLst>
-              <a:ext uri="{FF2B5EF4-FFF2-40B4-BE49-F238E27FC236}">
-                <a16:creationId xmlns:a16="http://schemas.microsoft.com/office/drawing/2014/main" id="{AB6583FE-B653-4C01-9ADF-EC8514A0B5ED}"/>
-              </a:ext>
-            </a:extLst>
-          </p:cNvPr>
-          <p:cNvSpPr>
-            <a:spLocks noGrp="1"/>
-          </p:cNvSpPr>
-          <p:nvPr>
-            <p:ph sz="quarter" idx="13"/>
-          </p:nvPr>
-        </p:nvSpPr>
-        <p:spPr>
-          <a:xfrm>
-            <a:off x="649288" y="2523744"/>
-            <a:ext cx="2862072" cy="3566160"/>
-          </a:xfrm>
-        </p:spPr>
-        <p:txBody>
-          <a:bodyPr>
-            <a:normAutofit/>
-          </a:bodyPr>
-          <a:lstStyle/>
-          <a:p>
-            <a:r>
-              <a:rPr lang="en-US" dirty="0"/>
-              <a:t>Meaning</a:t>
-            </a:r>
-          </a:p>
-        </p:txBody>
-      </p:sp>
-      <p:graphicFrame>
-        <p:nvGraphicFramePr>
-          <p:cNvPr id="3" name="Table Placeholder 2">
-            <a:extLst>
-              <a:ext uri="{FF2B5EF4-FFF2-40B4-BE49-F238E27FC236}">
-                <a16:creationId xmlns:a16="http://schemas.microsoft.com/office/drawing/2014/main" id="{E410A886-0778-53D6-B831-7F38A0E03B64}"/>
-              </a:ext>
-            </a:extLst>
-          </p:cNvPr>
-          <p:cNvGraphicFramePr>
-            <a:graphicFrameLocks noGrp="1"/>
-          </p:cNvGraphicFramePr>
-          <p:nvPr>
-            <p:ph sz="quarter" idx="14"/>
-            <p:extLst>
-              <p:ext uri="{D42A27DB-BD31-4B8C-83A1-F6EECF244321}">
-                <p14:modId xmlns:p14="http://schemas.microsoft.com/office/powerpoint/2010/main" val="1345682488"/>
-              </p:ext>
-            </p:extLst>
-          </p:nvPr>
-        </p:nvGraphicFramePr>
-        <p:xfrm>
-          <a:off x="3867150" y="2524125"/>
-          <a:ext cx="7811824" cy="3647088"/>
-        </p:xfrm>
-        <a:graphic>
-          <a:graphicData uri="http://schemas.openxmlformats.org/drawingml/2006/table">
-            <a:tbl>
-              <a:tblPr firstRow="1" bandRow="1">
-                <a:tableStyleId>{5C22544A-7EE6-4342-B048-85BDC9FD1C3A}</a:tableStyleId>
-              </a:tblPr>
-              <a:tblGrid>
-                <a:gridCol w="1952956">
-                  <a:extLst>
-                    <a:ext uri="{9D8B030D-6E8A-4147-A177-3AD203B41FA5}">
-                      <a16:colId xmlns:a16="http://schemas.microsoft.com/office/drawing/2014/main" val="127040821"/>
-                    </a:ext>
-                  </a:extLst>
-                </a:gridCol>
-                <a:gridCol w="1952956">
-                  <a:extLst>
-                    <a:ext uri="{9D8B030D-6E8A-4147-A177-3AD203B41FA5}">
-                      <a16:colId xmlns:a16="http://schemas.microsoft.com/office/drawing/2014/main" val="149845700"/>
-                    </a:ext>
-                  </a:extLst>
-                </a:gridCol>
-                <a:gridCol w="1952956">
-                  <a:extLst>
-                    <a:ext uri="{9D8B030D-6E8A-4147-A177-3AD203B41FA5}">
-                      <a16:colId xmlns:a16="http://schemas.microsoft.com/office/drawing/2014/main" val="3119692462"/>
-                    </a:ext>
-                  </a:extLst>
-                </a:gridCol>
-                <a:gridCol w="1952956">
-                  <a:extLst>
-                    <a:ext uri="{9D8B030D-6E8A-4147-A177-3AD203B41FA5}">
-                      <a16:colId xmlns:a16="http://schemas.microsoft.com/office/drawing/2014/main" val="3472639139"/>
-                    </a:ext>
-                  </a:extLst>
-                </a:gridCol>
-              </a:tblGrid>
-              <a:tr h="539479">
-                <a:tc>
-                  <a:txBody>
-                    <a:bodyPr/>
-                    <a:lstStyle/>
-                    <a:p>
-                      <a:pPr algn="ctr"/>
-                      <a:endParaRPr lang="en-US" dirty="0">
-                        <a:latin typeface="+mj-lt"/>
-                      </a:endParaRPr>
-                    </a:p>
-                  </a:txBody>
-                  <a:tcPr anchor="ctr"/>
-                </a:tc>
-                <a:tc>
-                  <a:txBody>
-                    <a:bodyPr/>
-                    <a:lstStyle/>
-                    <a:p>
-                      <a:pPr algn="ctr"/>
-                      <a:endParaRPr lang="en-US" dirty="0">
-                        <a:latin typeface="+mj-lt"/>
-                      </a:endParaRPr>
-                    </a:p>
-                  </a:txBody>
-                  <a:tcPr anchor="ctr"/>
-                </a:tc>
-                <a:tc>
-                  <a:txBody>
-                    <a:bodyPr/>
-                    <a:lstStyle/>
-                    <a:p>
-                      <a:pPr algn="ctr"/>
-                      <a:endParaRPr lang="en-US" dirty="0">
-                        <a:latin typeface="+mj-lt"/>
-                      </a:endParaRPr>
-                    </a:p>
-                  </a:txBody>
-                  <a:tcPr anchor="ctr"/>
-                </a:tc>
-                <a:tc>
-                  <a:txBody>
-                    <a:bodyPr/>
-                    <a:lstStyle/>
-                    <a:p>
-                      <a:pPr algn="ctr"/>
-                      <a:endParaRPr lang="en-US" dirty="0">
-                        <a:latin typeface="+mj-lt"/>
-                      </a:endParaRPr>
-                    </a:p>
-                  </a:txBody>
-                  <a:tcPr anchor="ctr"/>
-                </a:tc>
-                <a:extLst>
-                  <a:ext uri="{0D108BD9-81ED-4DB2-BD59-A6C34878D82A}">
-                    <a16:rowId xmlns:a16="http://schemas.microsoft.com/office/drawing/2014/main" val="3298013591"/>
-                  </a:ext>
-                </a:extLst>
-              </a:tr>
-              <a:tr h="591690">
-                <a:tc>
-                  <a:txBody>
-                    <a:bodyPr/>
-                    <a:lstStyle/>
-                    <a:p>
-                      <a:pPr algn="ctr"/>
-                      <a:endParaRPr lang="en-US" dirty="0"/>
-                    </a:p>
-                  </a:txBody>
-                  <a:tcPr anchor="ctr"/>
-                </a:tc>
-                <a:tc>
-                  <a:txBody>
-                    <a:bodyPr/>
-                    <a:lstStyle/>
-                    <a:p>
-                      <a:pPr algn="ctr"/>
-                      <a:endParaRPr lang="en-US" dirty="0"/>
-                    </a:p>
-                  </a:txBody>
-                  <a:tcPr anchor="ctr"/>
-                </a:tc>
-                <a:tc>
-                  <a:txBody>
-                    <a:bodyPr/>
-                    <a:lstStyle/>
-                    <a:p>
-                      <a:pPr algn="ctr"/>
-                      <a:endParaRPr lang="en-US" dirty="0"/>
-                    </a:p>
-                  </a:txBody>
-                  <a:tcPr anchor="ctr"/>
-                </a:tc>
-                <a:tc>
-                  <a:txBody>
-                    <a:bodyPr/>
-                    <a:lstStyle/>
-                    <a:p>
-                      <a:pPr algn="ctr"/>
-                      <a:endParaRPr lang="en-US" dirty="0"/>
-                    </a:p>
-                  </a:txBody>
-                  <a:tcPr anchor="ctr"/>
-                </a:tc>
-                <a:extLst>
-                  <a:ext uri="{0D108BD9-81ED-4DB2-BD59-A6C34878D82A}">
-                    <a16:rowId xmlns:a16="http://schemas.microsoft.com/office/drawing/2014/main" val="3873867931"/>
-                  </a:ext>
-                </a:extLst>
-              </a:tr>
-              <a:tr h="591690">
-                <a:tc>
-                  <a:txBody>
-                    <a:bodyPr/>
-                    <a:lstStyle/>
-                    <a:p>
-                      <a:pPr algn="ctr"/>
-                      <a:endParaRPr lang="en-US" dirty="0"/>
-                    </a:p>
-                  </a:txBody>
-                  <a:tcPr anchor="ctr"/>
-                </a:tc>
-                <a:tc>
-                  <a:txBody>
-                    <a:bodyPr/>
-                    <a:lstStyle/>
-                    <a:p>
-                      <a:pPr algn="ctr"/>
-                      <a:endParaRPr lang="en-US" dirty="0"/>
-                    </a:p>
-                  </a:txBody>
-                  <a:tcPr anchor="ctr"/>
-                </a:tc>
-                <a:tc>
-                  <a:txBody>
-                    <a:bodyPr/>
-                    <a:lstStyle/>
-                    <a:p>
-                      <a:pPr algn="ctr"/>
-                      <a:endParaRPr lang="en-US" dirty="0"/>
-                    </a:p>
-                  </a:txBody>
-                  <a:tcPr anchor="ctr"/>
-                </a:tc>
-                <a:tc>
-                  <a:txBody>
-                    <a:bodyPr/>
-                    <a:lstStyle/>
-                    <a:p>
-                      <a:pPr algn="ctr"/>
-                      <a:endParaRPr lang="en-US" dirty="0"/>
-                    </a:p>
-                  </a:txBody>
-                  <a:tcPr anchor="ctr"/>
-                </a:tc>
-                <a:extLst>
-                  <a:ext uri="{0D108BD9-81ED-4DB2-BD59-A6C34878D82A}">
-                    <a16:rowId xmlns:a16="http://schemas.microsoft.com/office/drawing/2014/main" val="85209771"/>
-                  </a:ext>
-                </a:extLst>
-              </a:tr>
-              <a:tr h="539479">
-                <a:tc>
-                  <a:txBody>
-                    <a:bodyPr/>
-                    <a:lstStyle/>
-                    <a:p>
-                      <a:pPr algn="ctr"/>
-                      <a:endParaRPr lang="en-US" dirty="0"/>
-                    </a:p>
-                  </a:txBody>
-                  <a:tcPr anchor="ctr"/>
-                </a:tc>
-                <a:tc>
-                  <a:txBody>
-                    <a:bodyPr/>
-                    <a:lstStyle/>
-                    <a:p>
-                      <a:pPr algn="ctr"/>
-                      <a:endParaRPr lang="en-US" dirty="0"/>
-                    </a:p>
-                  </a:txBody>
-                  <a:tcPr anchor="ctr"/>
-                </a:tc>
-                <a:tc>
-                  <a:txBody>
-                    <a:bodyPr/>
-                    <a:lstStyle/>
-                    <a:p>
-                      <a:pPr algn="ctr"/>
-                      <a:endParaRPr lang="en-US" dirty="0"/>
-                    </a:p>
-                  </a:txBody>
-                  <a:tcPr anchor="ctr"/>
-                </a:tc>
-                <a:tc>
-                  <a:txBody>
-                    <a:bodyPr/>
-                    <a:lstStyle/>
-                    <a:p>
-                      <a:pPr algn="ctr"/>
-                      <a:endParaRPr lang="en-US" dirty="0"/>
-                    </a:p>
-                  </a:txBody>
-                  <a:tcPr anchor="ctr"/>
-                </a:tc>
-                <a:extLst>
-                  <a:ext uri="{0D108BD9-81ED-4DB2-BD59-A6C34878D82A}">
-                    <a16:rowId xmlns:a16="http://schemas.microsoft.com/office/drawing/2014/main" val="4061031278"/>
-                  </a:ext>
-                </a:extLst>
-              </a:tr>
-              <a:tr h="539479">
-                <a:tc>
-                  <a:txBody>
-                    <a:bodyPr/>
-                    <a:lstStyle/>
-                    <a:p>
-                      <a:pPr algn="ctr"/>
-                      <a:endParaRPr lang="en-US" dirty="0"/>
-                    </a:p>
-                  </a:txBody>
-                  <a:tcPr anchor="ctr"/>
-                </a:tc>
-                <a:tc>
-                  <a:txBody>
-                    <a:bodyPr/>
-                    <a:lstStyle/>
-                    <a:p>
-                      <a:pPr algn="ctr"/>
-                      <a:endParaRPr lang="en-US" dirty="0"/>
-                    </a:p>
-                  </a:txBody>
-                  <a:tcPr anchor="ctr"/>
-                </a:tc>
-                <a:tc>
-                  <a:txBody>
-                    <a:bodyPr/>
-                    <a:lstStyle/>
-                    <a:p>
-                      <a:pPr algn="ctr"/>
-                      <a:endParaRPr lang="en-US" dirty="0"/>
-                    </a:p>
-                  </a:txBody>
-                  <a:tcPr anchor="ctr"/>
-                </a:tc>
-                <a:tc>
-                  <a:txBody>
-                    <a:bodyPr/>
-                    <a:lstStyle/>
-                    <a:p>
-                      <a:pPr algn="ctr"/>
-                      <a:endParaRPr lang="en-US" dirty="0"/>
-                    </a:p>
-                  </a:txBody>
-                  <a:tcPr anchor="ctr"/>
-                </a:tc>
-                <a:extLst>
-                  <a:ext uri="{0D108BD9-81ED-4DB2-BD59-A6C34878D82A}">
-                    <a16:rowId xmlns:a16="http://schemas.microsoft.com/office/drawing/2014/main" val="3591840781"/>
-                  </a:ext>
-                </a:extLst>
-              </a:tr>
-              <a:tr h="845271">
-                <a:tc>
-                  <a:txBody>
-                    <a:bodyPr/>
-                    <a:lstStyle/>
-                    <a:p>
-                      <a:pPr algn="ctr"/>
-                      <a:endParaRPr lang="en-US" dirty="0"/>
-                    </a:p>
-                  </a:txBody>
-                  <a:tcPr anchor="ctr"/>
-                </a:tc>
-                <a:tc>
-                  <a:txBody>
-                    <a:bodyPr/>
-                    <a:lstStyle/>
-                    <a:p>
-                      <a:pPr algn="ctr"/>
-                      <a:endParaRPr lang="en-US" dirty="0"/>
-                    </a:p>
-                  </a:txBody>
-                  <a:tcPr anchor="ctr"/>
-                </a:tc>
-                <a:tc>
-                  <a:txBody>
-                    <a:bodyPr/>
-                    <a:lstStyle/>
-                    <a:p>
-                      <a:pPr algn="ctr"/>
-                      <a:endParaRPr lang="en-US" dirty="0"/>
-                    </a:p>
-                  </a:txBody>
-                  <a:tcPr anchor="ctr"/>
-                </a:tc>
-                <a:tc>
-                  <a:txBody>
-                    <a:bodyPr/>
-                    <a:lstStyle/>
-                    <a:p>
-                      <a:pPr algn="ctr"/>
-                      <a:endParaRPr lang="en-US" dirty="0"/>
-                    </a:p>
-                  </a:txBody>
-                  <a:tcPr anchor="ctr"/>
-                </a:tc>
-                <a:extLst>
-                  <a:ext uri="{0D108BD9-81ED-4DB2-BD59-A6C34878D82A}">
-                    <a16:rowId xmlns:a16="http://schemas.microsoft.com/office/drawing/2014/main" val="335389741"/>
-                  </a:ext>
-                </a:extLst>
-              </a:tr>
-            </a:tbl>
-          </a:graphicData>
-        </a:graphic>
-      </p:graphicFrame>
-    </p:spTree>
-    <p:extLst>
-      <p:ext uri="{BB962C8B-B14F-4D97-AF65-F5344CB8AC3E}">
-        <p14:creationId xmlns:p14="http://schemas.microsoft.com/office/powerpoint/2010/main" val="203592317"/>
-      </p:ext>
-    </p:extLst>
-  </p:cSld>
-  <p:clrMapOvr>
-    <a:masterClrMapping/>
-  </p:clrMapOvr>
-</p:sld>
-</file>
-
 <file path=ppt/slides/slide6.xml><?xml version="1.0" encoding="utf-8"?>
-<p:sld xmlns:a="http://schemas.openxmlformats.org/drawingml/2006/main" xmlns:r="http://schemas.openxmlformats.org/officeDocument/2006/relationships" xmlns:p="http://schemas.openxmlformats.org/presentationml/2006/main">
-  <p:cSld>
-    <p:spTree>
-      <p:nvGrpSpPr>
-        <p:cNvPr id="1" name=""/>
-        <p:cNvGrpSpPr/>
-        <p:nvPr/>
-      </p:nvGrpSpPr>
-      <p:grpSpPr>
-        <a:xfrm>
-          <a:off x="0" y="0"/>
-          <a:ext cx="0" cy="0"/>
-          <a:chOff x="0" y="0"/>
-          <a:chExt cx="0" cy="0"/>
-        </a:xfrm>
-      </p:grpSpPr>
-      <p:sp>
-        <p:nvSpPr>
-          <p:cNvPr id="18" name="Title 17">
-            <a:extLst>
-              <a:ext uri="{FF2B5EF4-FFF2-40B4-BE49-F238E27FC236}">
-                <a16:creationId xmlns:a16="http://schemas.microsoft.com/office/drawing/2014/main" id="{9F2FEA60-F900-4C56-9486-48EA30926F6E}"/>
-              </a:ext>
-            </a:extLst>
-          </p:cNvPr>
-          <p:cNvSpPr>
-            <a:spLocks noGrp="1"/>
-          </p:cNvSpPr>
-          <p:nvPr>
-            <p:ph type="title"/>
-          </p:nvPr>
-        </p:nvSpPr>
-        <p:spPr>
-          <a:xfrm>
-            <a:off x="649045" y="363854"/>
-            <a:ext cx="10780955" cy="1243717"/>
-          </a:xfrm>
-        </p:spPr>
-        <p:txBody>
-          <a:bodyPr>
-            <a:normAutofit/>
-          </a:bodyPr>
-          <a:lstStyle/>
-          <a:p>
-            <a:r>
-              <a:rPr lang="en-US" dirty="0"/>
-              <a:t>Example measures</a:t>
-            </a:r>
-          </a:p>
-        </p:txBody>
-      </p:sp>
-      <p:graphicFrame>
-        <p:nvGraphicFramePr>
-          <p:cNvPr id="3" name="Table Placeholder 3">
-            <a:extLst>
-              <a:ext uri="{FF2B5EF4-FFF2-40B4-BE49-F238E27FC236}">
-                <a16:creationId xmlns:a16="http://schemas.microsoft.com/office/drawing/2014/main" id="{DAA2584B-E55D-7E22-AD24-417D9C152A2D}"/>
-              </a:ext>
-            </a:extLst>
-          </p:cNvPr>
-          <p:cNvGraphicFramePr>
-            <a:graphicFrameLocks noGrp="1"/>
-          </p:cNvGraphicFramePr>
-          <p:nvPr>
-            <p:ph sz="quarter" idx="13"/>
-            <p:extLst>
-              <p:ext uri="{D42A27DB-BD31-4B8C-83A1-F6EECF244321}">
-                <p14:modId xmlns:p14="http://schemas.microsoft.com/office/powerpoint/2010/main" val="3138359314"/>
-              </p:ext>
-            </p:extLst>
-          </p:nvPr>
-        </p:nvGraphicFramePr>
-        <p:xfrm>
-          <a:off x="649288" y="2524125"/>
-          <a:ext cx="10704756" cy="3657599"/>
-        </p:xfrm>
-        <a:graphic>
-          <a:graphicData uri="http://schemas.openxmlformats.org/drawingml/2006/table">
-            <a:tbl>
-              <a:tblPr firstRow="1" bandRow="1">
-                <a:tableStyleId>{5C22544A-7EE6-4342-B048-85BDC9FD1C3A}</a:tableStyleId>
-              </a:tblPr>
-              <a:tblGrid>
-                <a:gridCol w="2676189">
-                  <a:extLst>
-                    <a:ext uri="{9D8B030D-6E8A-4147-A177-3AD203B41FA5}">
-                      <a16:colId xmlns:a16="http://schemas.microsoft.com/office/drawing/2014/main" val="2382218087"/>
-                    </a:ext>
-                  </a:extLst>
-                </a:gridCol>
-                <a:gridCol w="2676189">
-                  <a:extLst>
-                    <a:ext uri="{9D8B030D-6E8A-4147-A177-3AD203B41FA5}">
-                      <a16:colId xmlns:a16="http://schemas.microsoft.com/office/drawing/2014/main" val="3953468724"/>
-                    </a:ext>
-                  </a:extLst>
-                </a:gridCol>
-                <a:gridCol w="2676189">
-                  <a:extLst>
-                    <a:ext uri="{9D8B030D-6E8A-4147-A177-3AD203B41FA5}">
-                      <a16:colId xmlns:a16="http://schemas.microsoft.com/office/drawing/2014/main" val="4277526474"/>
-                    </a:ext>
-                  </a:extLst>
-                </a:gridCol>
-                <a:gridCol w="2676189">
-                  <a:extLst>
-                    <a:ext uri="{9D8B030D-6E8A-4147-A177-3AD203B41FA5}">
-                      <a16:colId xmlns:a16="http://schemas.microsoft.com/office/drawing/2014/main" val="2438884888"/>
-                    </a:ext>
-                  </a:extLst>
-                </a:gridCol>
-              </a:tblGrid>
-              <a:tr h="576704">
-                <a:tc>
-                  <a:txBody>
-                    <a:bodyPr/>
-                    <a:lstStyle/>
-                    <a:p>
-                      <a:pPr algn="ctr"/>
-                      <a:endParaRPr lang="en-US" dirty="0">
-                        <a:latin typeface="+mj-lt"/>
-                      </a:endParaRPr>
-                    </a:p>
-                  </a:txBody>
-                  <a:tcPr anchor="ctr"/>
-                </a:tc>
-                <a:tc>
-                  <a:txBody>
-                    <a:bodyPr/>
-                    <a:lstStyle/>
-                    <a:p>
-                      <a:pPr algn="ctr"/>
-                      <a:endParaRPr lang="en-US" dirty="0">
-                        <a:latin typeface="+mj-lt"/>
-                      </a:endParaRPr>
-                    </a:p>
-                  </a:txBody>
-                  <a:tcPr anchor="ctr"/>
-                </a:tc>
-                <a:tc>
-                  <a:txBody>
-                    <a:bodyPr/>
-                    <a:lstStyle/>
-                    <a:p>
-                      <a:pPr algn="ctr"/>
-                      <a:endParaRPr lang="en-US" dirty="0">
-                        <a:latin typeface="+mj-lt"/>
-                      </a:endParaRPr>
-                    </a:p>
-                  </a:txBody>
-                  <a:tcPr anchor="ctr"/>
-                </a:tc>
-                <a:tc>
-                  <a:txBody>
-                    <a:bodyPr/>
-                    <a:lstStyle/>
-                    <a:p>
-                      <a:pPr algn="ctr"/>
-                      <a:endParaRPr lang="en-US" dirty="0">
-                        <a:latin typeface="+mj-lt"/>
-                      </a:endParaRPr>
-                    </a:p>
-                  </a:txBody>
-                  <a:tcPr anchor="ctr"/>
-                </a:tc>
-                <a:extLst>
-                  <a:ext uri="{0D108BD9-81ED-4DB2-BD59-A6C34878D82A}">
-                    <a16:rowId xmlns:a16="http://schemas.microsoft.com/office/drawing/2014/main" val="2857107962"/>
-                  </a:ext>
-                </a:extLst>
-              </a:tr>
-              <a:tr h="616179">
-                <a:tc>
-                  <a:txBody>
-                    <a:bodyPr/>
-                    <a:lstStyle/>
-                    <a:p>
-                      <a:pPr algn="ctr"/>
-                      <a:endParaRPr lang="en-US" dirty="0"/>
-                    </a:p>
-                  </a:txBody>
-                  <a:tcPr anchor="ctr"/>
-                </a:tc>
-                <a:tc>
-                  <a:txBody>
-                    <a:bodyPr/>
-                    <a:lstStyle/>
-                    <a:p>
-                      <a:pPr algn="ctr"/>
-                      <a:endParaRPr lang="en-US" dirty="0"/>
-                    </a:p>
-                  </a:txBody>
-                  <a:tcPr anchor="ctr"/>
-                </a:tc>
-                <a:tc>
-                  <a:txBody>
-                    <a:bodyPr/>
-                    <a:lstStyle/>
-                    <a:p>
-                      <a:pPr algn="ctr"/>
-                      <a:endParaRPr lang="en-US" dirty="0"/>
-                    </a:p>
-                  </a:txBody>
-                  <a:tcPr anchor="ctr"/>
-                </a:tc>
-                <a:tc>
-                  <a:txBody>
-                    <a:bodyPr/>
-                    <a:lstStyle/>
-                    <a:p>
-                      <a:pPr algn="ctr"/>
-                      <a:endParaRPr lang="en-US" dirty="0"/>
-                    </a:p>
-                  </a:txBody>
-                  <a:tcPr anchor="ctr"/>
-                </a:tc>
-                <a:extLst>
-                  <a:ext uri="{0D108BD9-81ED-4DB2-BD59-A6C34878D82A}">
-                    <a16:rowId xmlns:a16="http://schemas.microsoft.com/office/drawing/2014/main" val="1671386868"/>
-                  </a:ext>
-                </a:extLst>
-              </a:tr>
-              <a:tr h="616179">
-                <a:tc>
-                  <a:txBody>
-                    <a:bodyPr/>
-                    <a:lstStyle/>
-                    <a:p>
-                      <a:pPr algn="ctr"/>
-                      <a:endParaRPr lang="en-US" dirty="0"/>
-                    </a:p>
-                  </a:txBody>
-                  <a:tcPr anchor="ctr"/>
-                </a:tc>
-                <a:tc>
-                  <a:txBody>
-                    <a:bodyPr/>
-                    <a:lstStyle/>
-                    <a:p>
-                      <a:pPr algn="ctr"/>
-                      <a:endParaRPr lang="en-US" dirty="0"/>
-                    </a:p>
-                  </a:txBody>
-                  <a:tcPr anchor="ctr"/>
-                </a:tc>
-                <a:tc>
-                  <a:txBody>
-                    <a:bodyPr/>
-                    <a:lstStyle/>
-                    <a:p>
-                      <a:pPr algn="ctr"/>
-                      <a:endParaRPr lang="en-US" dirty="0"/>
-                    </a:p>
-                  </a:txBody>
-                  <a:tcPr anchor="ctr"/>
-                </a:tc>
-                <a:tc>
-                  <a:txBody>
-                    <a:bodyPr/>
-                    <a:lstStyle/>
-                    <a:p>
-                      <a:pPr algn="ctr"/>
-                      <a:endParaRPr lang="en-US" dirty="0"/>
-                    </a:p>
-                  </a:txBody>
-                  <a:tcPr anchor="ctr"/>
-                </a:tc>
-                <a:extLst>
-                  <a:ext uri="{0D108BD9-81ED-4DB2-BD59-A6C34878D82A}">
-                    <a16:rowId xmlns:a16="http://schemas.microsoft.com/office/drawing/2014/main" val="380626418"/>
-                  </a:ext>
-                </a:extLst>
-              </a:tr>
-              <a:tr h="616179">
-                <a:tc>
-                  <a:txBody>
-                    <a:bodyPr/>
-                    <a:lstStyle/>
-                    <a:p>
-                      <a:pPr algn="ctr"/>
-                      <a:endParaRPr lang="en-US" dirty="0"/>
-                    </a:p>
-                  </a:txBody>
-                  <a:tcPr anchor="ctr"/>
-                </a:tc>
-                <a:tc>
-                  <a:txBody>
-                    <a:bodyPr/>
-                    <a:lstStyle/>
-                    <a:p>
-                      <a:pPr algn="ctr"/>
-                      <a:endParaRPr lang="en-US" dirty="0"/>
-                    </a:p>
-                  </a:txBody>
-                  <a:tcPr anchor="ctr"/>
-                </a:tc>
-                <a:tc>
-                  <a:txBody>
-                    <a:bodyPr/>
-                    <a:lstStyle/>
-                    <a:p>
-                      <a:pPr algn="ctr"/>
-                      <a:endParaRPr lang="en-US" dirty="0"/>
-                    </a:p>
-                  </a:txBody>
-                  <a:tcPr anchor="ctr"/>
-                </a:tc>
-                <a:tc>
-                  <a:txBody>
-                    <a:bodyPr/>
-                    <a:lstStyle/>
-                    <a:p>
-                      <a:pPr algn="ctr"/>
-                      <a:endParaRPr lang="en-US" dirty="0"/>
-                    </a:p>
-                  </a:txBody>
-                  <a:tcPr anchor="ctr"/>
-                </a:tc>
-                <a:extLst>
-                  <a:ext uri="{0D108BD9-81ED-4DB2-BD59-A6C34878D82A}">
-                    <a16:rowId xmlns:a16="http://schemas.microsoft.com/office/drawing/2014/main" val="2132482967"/>
-                  </a:ext>
-                </a:extLst>
-              </a:tr>
-              <a:tr h="616179">
-                <a:tc>
-                  <a:txBody>
-                    <a:bodyPr/>
-                    <a:lstStyle/>
-                    <a:p>
-                      <a:pPr algn="ctr"/>
-                      <a:endParaRPr lang="en-US" dirty="0"/>
-                    </a:p>
-                  </a:txBody>
-                  <a:tcPr anchor="ctr"/>
-                </a:tc>
-                <a:tc>
-                  <a:txBody>
-                    <a:bodyPr/>
-                    <a:lstStyle/>
-                    <a:p>
-                      <a:pPr algn="ctr"/>
-                      <a:endParaRPr lang="en-US" dirty="0"/>
-                    </a:p>
-                  </a:txBody>
-                  <a:tcPr anchor="ctr"/>
-                </a:tc>
-                <a:tc>
-                  <a:txBody>
-                    <a:bodyPr/>
-                    <a:lstStyle/>
-                    <a:p>
-                      <a:pPr algn="ctr"/>
-                      <a:endParaRPr lang="en-US" dirty="0"/>
-                    </a:p>
-                  </a:txBody>
-                  <a:tcPr anchor="ctr"/>
-                </a:tc>
-                <a:tc>
-                  <a:txBody>
-                    <a:bodyPr/>
-                    <a:lstStyle/>
-                    <a:p>
-                      <a:pPr algn="ctr"/>
-                      <a:endParaRPr lang="en-US" dirty="0"/>
-                    </a:p>
-                  </a:txBody>
-                  <a:tcPr anchor="ctr"/>
-                </a:tc>
-                <a:extLst>
-                  <a:ext uri="{0D108BD9-81ED-4DB2-BD59-A6C34878D82A}">
-                    <a16:rowId xmlns:a16="http://schemas.microsoft.com/office/drawing/2014/main" val="3936251906"/>
-                  </a:ext>
-                </a:extLst>
-              </a:tr>
-              <a:tr h="616179">
-                <a:tc>
-                  <a:txBody>
-                    <a:bodyPr/>
-                    <a:lstStyle/>
-                    <a:p>
-                      <a:pPr algn="ctr"/>
-                      <a:endParaRPr lang="en-US" dirty="0"/>
-                    </a:p>
-                  </a:txBody>
-                  <a:tcPr anchor="ctr"/>
-                </a:tc>
-                <a:tc>
-                  <a:txBody>
-                    <a:bodyPr/>
-                    <a:lstStyle/>
-                    <a:p>
-                      <a:pPr algn="ctr"/>
-                      <a:endParaRPr lang="en-US" dirty="0"/>
-                    </a:p>
-                  </a:txBody>
-                  <a:tcPr anchor="ctr"/>
-                </a:tc>
-                <a:tc>
-                  <a:txBody>
-                    <a:bodyPr/>
-                    <a:lstStyle/>
-                    <a:p>
-                      <a:pPr algn="ctr"/>
-                      <a:endParaRPr lang="en-US" dirty="0"/>
-                    </a:p>
-                  </a:txBody>
-                  <a:tcPr anchor="ctr"/>
-                </a:tc>
-                <a:tc>
-                  <a:txBody>
-                    <a:bodyPr/>
-                    <a:lstStyle/>
-                    <a:p>
-                      <a:pPr algn="ctr"/>
-                      <a:endParaRPr lang="en-US" dirty="0"/>
-                    </a:p>
-                  </a:txBody>
-                  <a:tcPr anchor="ctr"/>
-                </a:tc>
-                <a:extLst>
-                  <a:ext uri="{0D108BD9-81ED-4DB2-BD59-A6C34878D82A}">
-                    <a16:rowId xmlns:a16="http://schemas.microsoft.com/office/drawing/2014/main" val="568537164"/>
-                  </a:ext>
-                </a:extLst>
-              </a:tr>
-            </a:tbl>
-          </a:graphicData>
-        </a:graphic>
-      </p:graphicFrame>
-    </p:spTree>
-    <p:extLst>
-      <p:ext uri="{BB962C8B-B14F-4D97-AF65-F5344CB8AC3E}">
-        <p14:creationId xmlns:p14="http://schemas.microsoft.com/office/powerpoint/2010/main" val="2098197778"/>
-      </p:ext>
-    </p:extLst>
-  </p:cSld>
-  <p:clrMapOvr>
-    <a:masterClrMapping/>
-  </p:clrMapOvr>
-</p:sld>
-</file>
-
-<file path=ppt/slides/slide7.xml><?xml version="1.0" encoding="utf-8"?>
 <p:sld xmlns:a="http://schemas.openxmlformats.org/drawingml/2006/main" xmlns:r="http://schemas.openxmlformats.org/officeDocument/2006/relationships" xmlns:p="http://schemas.openxmlformats.org/presentationml/2006/main">
   <p:cSld>
     <p:spTree>
@@ -12845,6 +12025,35 @@
 </file>
 
 <file path=customXml/item1.xml><?xml version="1.0" encoding="utf-8"?>
+<p:properties xmlns:p="http://schemas.microsoft.com/office/2006/metadata/properties" xmlns:xsi="http://www.w3.org/2001/XMLSchema-instance" xmlns:pc="http://schemas.microsoft.com/office/infopath/2007/PartnerControls">
+  <documentManagement>
+    <MediaServiceKeyPoints xmlns="71af3243-3dd4-4a8d-8c0d-dd76da1f02a5" xsi:nil="true"/>
+    <Background xmlns="71af3243-3dd4-4a8d-8c0d-dd76da1f02a5">false</Background>
+    <Status xmlns="71af3243-3dd4-4a8d-8c0d-dd76da1f02a5">Not started</Status>
+    <TaxCatchAll xmlns="230e9df3-be65-4c73-a93b-d1236ebd677e" xsi:nil="true"/>
+    <ImageTagsTaxHTField xmlns="71af3243-3dd4-4a8d-8c0d-dd76da1f02a5">
+      <Terms xmlns="http://schemas.microsoft.com/office/infopath/2007/PartnerControls"/>
+    </ImageTagsTaxHTField>
+    <Image xmlns="71af3243-3dd4-4a8d-8c0d-dd76da1f02a5">
+      <Url xsi:nil="true"/>
+      <Description xsi:nil="true"/>
+    </Image>
+    <_ip_UnifiedCompliancePolicyUIAction xmlns="http://schemas.microsoft.com/sharepoint/v3" xsi:nil="true"/>
+    <_ip_UnifiedCompliancePolicyProperties xmlns="http://schemas.microsoft.com/sharepoint/v3" xsi:nil="true"/>
+  </documentManagement>
+</p:properties>
+</file>
+
+<file path=customXml/item2.xml><?xml version="1.0" encoding="utf-8"?>
+<?mso-contentType ?>
+<FormTemplates xmlns="http://schemas.microsoft.com/sharepoint/v3/contenttype/forms">
+  <Display>DocumentLibraryForm</Display>
+  <Edit>DocumentLibraryForm</Edit>
+  <New>DocumentLibraryForm</New>
+</FormTemplates>
+</file>
+
+<file path=customXml/item3.xml><?xml version="1.0" encoding="utf-8"?>
 <ct:contentTypeSchema xmlns:ct="http://schemas.microsoft.com/office/2006/metadata/contentType" xmlns:ma="http://schemas.microsoft.com/office/2006/metadata/properties/metaAttributes" ct:_="" ma:_="" ma:contentTypeName="Document" ma:contentTypeID="0x01010079F111ED35F8CC479449609E8A0923A6" ma:contentTypeVersion="28" ma:contentTypeDescription="Create a new document." ma:contentTypeScope="" ma:versionID="60f5a4f2d2b0abadcf532d48ebf9cb71">
   <xsd:schema xmlns:xsd="http://www.w3.org/2001/XMLSchema" xmlns:xs="http://www.w3.org/2001/XMLSchema" xmlns:p="http://schemas.microsoft.com/office/2006/metadata/properties" xmlns:ns1="http://schemas.microsoft.com/sharepoint/v3" xmlns:ns2="71af3243-3dd4-4a8d-8c0d-dd76da1f02a5" xmlns:ns3="16c05727-aa75-4e4a-9b5f-8a80a1165891" xmlns:ns4="230e9df3-be65-4c73-a93b-d1236ebd677e" targetNamespace="http://schemas.microsoft.com/office/2006/metadata/properties" ma:root="true" ma:fieldsID="7dd78129e6a1811f84807ad11c651531" ns1:_="" ns2:_="" ns3:_="" ns4:_="">
     <xsd:import namespace="http://schemas.microsoft.com/sharepoint/v3"/>
@@ -13156,36 +12365,27 @@
 </ct:contentTypeSchema>
 </file>
 
-<file path=customXml/item2.xml><?xml version="1.0" encoding="utf-8"?>
-<?mso-contentType ?>
-<FormTemplates xmlns="http://schemas.microsoft.com/sharepoint/v3/contenttype/forms">
-  <Display>DocumentLibraryForm</Display>
-  <Edit>DocumentLibraryForm</Edit>
-  <New>DocumentLibraryForm</New>
-</FormTemplates>
+<file path=customXml/itemProps1.xml><?xml version="1.0" encoding="utf-8"?>
+<ds:datastoreItem xmlns:ds="http://schemas.openxmlformats.org/officeDocument/2006/customXml" ds:itemID="{BE526E5B-BE06-44ED-944C-46B3BE1A406A}">
+  <ds:schemaRefs>
+    <ds:schemaRef ds:uri="http://schemas.microsoft.com/office/2006/metadata/properties"/>
+    <ds:schemaRef ds:uri="http://schemas.microsoft.com/office/infopath/2007/PartnerControls"/>
+    <ds:schemaRef ds:uri="71af3243-3dd4-4a8d-8c0d-dd76da1f02a5"/>
+    <ds:schemaRef ds:uri="230e9df3-be65-4c73-a93b-d1236ebd677e"/>
+    <ds:schemaRef ds:uri="http://schemas.microsoft.com/sharepoint/v3"/>
+  </ds:schemaRefs>
+</ds:datastoreItem>
 </file>
 
-<file path=customXml/item3.xml><?xml version="1.0" encoding="utf-8"?>
-<p:properties xmlns:p="http://schemas.microsoft.com/office/2006/metadata/properties" xmlns:xsi="http://www.w3.org/2001/XMLSchema-instance" xmlns:pc="http://schemas.microsoft.com/office/infopath/2007/PartnerControls">
-  <documentManagement>
-    <MediaServiceKeyPoints xmlns="71af3243-3dd4-4a8d-8c0d-dd76da1f02a5" xsi:nil="true"/>
-    <Background xmlns="71af3243-3dd4-4a8d-8c0d-dd76da1f02a5">false</Background>
-    <Status xmlns="71af3243-3dd4-4a8d-8c0d-dd76da1f02a5">Not started</Status>
-    <TaxCatchAll xmlns="230e9df3-be65-4c73-a93b-d1236ebd677e" xsi:nil="true"/>
-    <ImageTagsTaxHTField xmlns="71af3243-3dd4-4a8d-8c0d-dd76da1f02a5">
-      <Terms xmlns="http://schemas.microsoft.com/office/infopath/2007/PartnerControls"/>
-    </ImageTagsTaxHTField>
-    <Image xmlns="71af3243-3dd4-4a8d-8c0d-dd76da1f02a5">
-      <Url xsi:nil="true"/>
-      <Description xsi:nil="true"/>
-    </Image>
-    <_ip_UnifiedCompliancePolicyUIAction xmlns="http://schemas.microsoft.com/sharepoint/v3" xsi:nil="true"/>
-    <_ip_UnifiedCompliancePolicyProperties xmlns="http://schemas.microsoft.com/sharepoint/v3" xsi:nil="true"/>
-  </documentManagement>
-</p:properties>
+<file path=customXml/itemProps2.xml><?xml version="1.0" encoding="utf-8"?>
+<ds:datastoreItem xmlns:ds="http://schemas.openxmlformats.org/officeDocument/2006/customXml" ds:itemID="{5E4B3662-E706-427A-8C63-55F1C5B1CAE0}">
+  <ds:schemaRefs>
+    <ds:schemaRef ds:uri="http://schemas.microsoft.com/sharepoint/v3/contenttype/forms"/>
+  </ds:schemaRefs>
+</ds:datastoreItem>
 </file>
 
-<file path=customXml/itemProps1.xml><?xml version="1.0" encoding="utf-8"?>
+<file path=customXml/itemProps3.xml><?xml version="1.0" encoding="utf-8"?>
 <ds:datastoreItem xmlns:ds="http://schemas.openxmlformats.org/officeDocument/2006/customXml" ds:itemID="{2DD5551C-388C-42EB-B1BB-B0BF4434BACB}">
   <ds:schemaRefs>
     <ds:schemaRef ds:uri="http://schemas.microsoft.com/office/2006/metadata/contentType"/>
@@ -13206,26 +12406,6 @@
 </ds:datastoreItem>
 </file>
 
-<file path=customXml/itemProps2.xml><?xml version="1.0" encoding="utf-8"?>
-<ds:datastoreItem xmlns:ds="http://schemas.openxmlformats.org/officeDocument/2006/customXml" ds:itemID="{5E4B3662-E706-427A-8C63-55F1C5B1CAE0}">
-  <ds:schemaRefs>
-    <ds:schemaRef ds:uri="http://schemas.microsoft.com/sharepoint/v3/contenttype/forms"/>
-  </ds:schemaRefs>
-</ds:datastoreItem>
-</file>
-
-<file path=customXml/itemProps3.xml><?xml version="1.0" encoding="utf-8"?>
-<ds:datastoreItem xmlns:ds="http://schemas.openxmlformats.org/officeDocument/2006/customXml" ds:itemID="{BE526E5B-BE06-44ED-944C-46B3BE1A406A}">
-  <ds:schemaRefs>
-    <ds:schemaRef ds:uri="http://schemas.microsoft.com/office/2006/metadata/properties"/>
-    <ds:schemaRef ds:uri="http://schemas.microsoft.com/office/infopath/2007/PartnerControls"/>
-    <ds:schemaRef ds:uri="71af3243-3dd4-4a8d-8c0d-dd76da1f02a5"/>
-    <ds:schemaRef ds:uri="230e9df3-be65-4c73-a93b-d1236ebd677e"/>
-    <ds:schemaRef ds:uri="http://schemas.microsoft.com/sharepoint/v3"/>
-  </ds:schemaRefs>
-</ds:datastoreItem>
-</file>
-
 <file path=docMetadata/LabelInfo.xml><?xml version="1.0" encoding="utf-8"?>
 <clbl:labelList xmlns:clbl="http://schemas.microsoft.com/office/2020/mipLabelMetadata"/>
 </file>
</xml_diff>